<commit_message>
Product- Show created datas at datatable
</commit_message>
<xml_diff>
--- a/.lessons/58 Backend Product And Related Features/13 Product- Show created datas at datatable/1.pptx
+++ b/.lessons/58 Backend Product And Related Features/13 Product- Show created datas at datatable/1.pptx
@@ -7,7 +7,11 @@
   <p:sldIdLst>
     <p:sldId id="413" r:id="rId2"/>
     <p:sldId id="414" r:id="rId3"/>
-    <p:sldId id="400" r:id="rId4"/>
+    <p:sldId id="415" r:id="rId4"/>
+    <p:sldId id="416" r:id="rId5"/>
+    <p:sldId id="417" r:id="rId6"/>
+    <p:sldId id="418" r:id="rId7"/>
+    <p:sldId id="400" r:id="rId8"/>
   </p:sldIdLst>
   <p:sldSz cx="12192000" cy="6858000"/>
   <p:notesSz cx="6858000" cy="9144000"/>
@@ -261,7 +265,7 @@
           <a:p>
             <a:fld id="{3E102D2E-813C-461C-9963-687A650C48C0}" type="datetimeFigureOut">
               <a:rPr lang="en-US" smtClean="0"/>
-              <a:t>6/26/2025</a:t>
+              <a:t>10/7/2025</a:t>
             </a:fld>
             <a:endParaRPr lang="en-US"/>
           </a:p>
@@ -459,7 +463,7 @@
           <a:p>
             <a:fld id="{3E102D2E-813C-461C-9963-687A650C48C0}" type="datetimeFigureOut">
               <a:rPr lang="en-US" smtClean="0"/>
-              <a:t>6/26/2025</a:t>
+              <a:t>10/7/2025</a:t>
             </a:fld>
             <a:endParaRPr lang="en-US"/>
           </a:p>
@@ -667,7 +671,7 @@
           <a:p>
             <a:fld id="{3E102D2E-813C-461C-9963-687A650C48C0}" type="datetimeFigureOut">
               <a:rPr lang="en-US" smtClean="0"/>
-              <a:t>6/26/2025</a:t>
+              <a:t>10/7/2025</a:t>
             </a:fld>
             <a:endParaRPr lang="en-US"/>
           </a:p>
@@ -865,7 +869,7 @@
           <a:p>
             <a:fld id="{3E102D2E-813C-461C-9963-687A650C48C0}" type="datetimeFigureOut">
               <a:rPr lang="en-US" smtClean="0"/>
-              <a:t>6/26/2025</a:t>
+              <a:t>10/7/2025</a:t>
             </a:fld>
             <a:endParaRPr lang="en-US"/>
           </a:p>
@@ -1140,7 +1144,7 @@
           <a:p>
             <a:fld id="{3E102D2E-813C-461C-9963-687A650C48C0}" type="datetimeFigureOut">
               <a:rPr lang="en-US" smtClean="0"/>
-              <a:t>6/26/2025</a:t>
+              <a:t>10/7/2025</a:t>
             </a:fld>
             <a:endParaRPr lang="en-US"/>
           </a:p>
@@ -1405,7 +1409,7 @@
           <a:p>
             <a:fld id="{3E102D2E-813C-461C-9963-687A650C48C0}" type="datetimeFigureOut">
               <a:rPr lang="en-US" smtClean="0"/>
-              <a:t>6/26/2025</a:t>
+              <a:t>10/7/2025</a:t>
             </a:fld>
             <a:endParaRPr lang="en-US"/>
           </a:p>
@@ -1817,7 +1821,7 @@
           <a:p>
             <a:fld id="{3E102D2E-813C-461C-9963-687A650C48C0}" type="datetimeFigureOut">
               <a:rPr lang="en-US" smtClean="0"/>
-              <a:t>6/26/2025</a:t>
+              <a:t>10/7/2025</a:t>
             </a:fld>
             <a:endParaRPr lang="en-US"/>
           </a:p>
@@ -1958,7 +1962,7 @@
           <a:p>
             <a:fld id="{3E102D2E-813C-461C-9963-687A650C48C0}" type="datetimeFigureOut">
               <a:rPr lang="en-US" smtClean="0"/>
-              <a:t>6/26/2025</a:t>
+              <a:t>10/7/2025</a:t>
             </a:fld>
             <a:endParaRPr lang="en-US"/>
           </a:p>
@@ -2071,7 +2075,7 @@
           <a:p>
             <a:fld id="{3E102D2E-813C-461C-9963-687A650C48C0}" type="datetimeFigureOut">
               <a:rPr lang="en-US" smtClean="0"/>
-              <a:t>6/26/2025</a:t>
+              <a:t>10/7/2025</a:t>
             </a:fld>
             <a:endParaRPr lang="en-US"/>
           </a:p>
@@ -2382,7 +2386,7 @@
           <a:p>
             <a:fld id="{3E102D2E-813C-461C-9963-687A650C48C0}" type="datetimeFigureOut">
               <a:rPr lang="en-US" smtClean="0"/>
-              <a:t>6/26/2025</a:t>
+              <a:t>10/7/2025</a:t>
             </a:fld>
             <a:endParaRPr lang="en-US"/>
           </a:p>
@@ -2670,7 +2674,7 @@
           <a:p>
             <a:fld id="{3E102D2E-813C-461C-9963-687A650C48C0}" type="datetimeFigureOut">
               <a:rPr lang="en-US" smtClean="0"/>
-              <a:t>6/26/2025</a:t>
+              <a:t>10/7/2025</a:t>
             </a:fld>
             <a:endParaRPr lang="en-US"/>
           </a:p>
@@ -2911,7 +2915,7 @@
           <a:p>
             <a:fld id="{3E102D2E-813C-461C-9963-687A650C48C0}" type="datetimeFigureOut">
               <a:rPr lang="en-US" smtClean="0"/>
-              <a:t>6/26/2025</a:t>
+              <a:t>10/7/2025</a:t>
             </a:fld>
             <a:endParaRPr lang="en-US"/>
           </a:p>
@@ -3348,8 +3352,8 @@
         </p:nvSpPr>
         <p:spPr>
           <a:xfrm>
-            <a:off x="217714" y="255046"/>
-            <a:ext cx="11756571" cy="355354"/>
+            <a:off x="217714" y="116500"/>
+            <a:ext cx="11756571" cy="1166153"/>
           </a:xfrm>
           <a:prstGeom prst="rect">
             <a:avLst/>
@@ -3369,21 +3373,118 @@
               <a:buNone/>
             </a:pPr>
             <a:r>
-              <a:rPr kumimoji="0" lang="en-US" altLang="en-US" sz="1300" b="0" i="0" u="none" strike="noStrike" cap="none" normalizeH="0" baseline="0">
-                <a:ln>
-                  <a:noFill/>
-                </a:ln>
-                <a:solidFill>
-                  <a:schemeClr val="tx1"/>
-                </a:solidFill>
-                <a:effectLst/>
+              <a:rPr lang="en-US" altLang="en-US" sz="1200" b="1">
                 <a:latin typeface="Arial" panose="020B0604020202020204" pitchFamily="34" charset="0"/>
               </a:rPr>
-              <a:t>.</a:t>
-            </a:r>
-          </a:p>
-        </p:txBody>
-      </p:sp>
+              <a:t>app\DataTables\ProductDataTable.php</a:t>
+            </a:r>
+            <a:r>
+              <a:rPr lang="az-Latn-AZ" altLang="en-US" sz="1200" b="1">
+                <a:latin typeface="Arial" panose="020B0604020202020204" pitchFamily="34" charset="0"/>
+              </a:rPr>
+              <a:t> </a:t>
+            </a:r>
+            <a:r>
+              <a:rPr lang="az-Latn-AZ" altLang="en-US" sz="1200">
+                <a:latin typeface="Arial" panose="020B0604020202020204" pitchFamily="34" charset="0"/>
+              </a:rPr>
+              <a:t>- şablonda dataların göstərilməsi üçün </a:t>
+            </a:r>
+            <a:r>
+              <a:rPr lang="az-Latn-AZ" altLang="en-US" sz="1200" b="1">
+                <a:latin typeface="Arial" panose="020B0604020202020204" pitchFamily="34" charset="0"/>
+              </a:rPr>
+              <a:t>ProductDataTable</a:t>
+            </a:r>
+            <a:r>
+              <a:rPr lang="az-Latn-AZ" altLang="en-US" sz="1200">
+                <a:latin typeface="Arial" panose="020B0604020202020204" pitchFamily="34" charset="0"/>
+              </a:rPr>
+              <a:t> faylını redaktə edirik.</a:t>
+            </a:r>
+          </a:p>
+          <a:p>
+            <a:pPr>
+              <a:lnSpc>
+                <a:spcPct val="150000"/>
+              </a:lnSpc>
+              <a:buNone/>
+            </a:pPr>
+            <a:endParaRPr kumimoji="0" lang="az-Latn-AZ" altLang="en-US" sz="1200" b="0" i="0" u="none" strike="noStrike" cap="none" normalizeH="0" baseline="0">
+              <a:ln>
+                <a:noFill/>
+              </a:ln>
+              <a:solidFill>
+                <a:schemeClr val="tx1"/>
+              </a:solidFill>
+              <a:effectLst/>
+              <a:latin typeface="Arial" panose="020B0604020202020204" pitchFamily="34" charset="0"/>
+            </a:endParaRPr>
+          </a:p>
+          <a:p>
+            <a:pPr>
+              <a:lnSpc>
+                <a:spcPct val="150000"/>
+              </a:lnSpc>
+              <a:buNone/>
+            </a:pPr>
+            <a:r>
+              <a:rPr lang="az-Latn-AZ" altLang="en-US" sz="1200">
+                <a:latin typeface="Arial" panose="020B0604020202020204" pitchFamily="34" charset="0"/>
+              </a:rPr>
+              <a:t>Kod uzun olduğu üçün hissə-hissə yerləşdirəcəm.</a:t>
+            </a:r>
+          </a:p>
+          <a:p>
+            <a:pPr>
+              <a:lnSpc>
+                <a:spcPct val="150000"/>
+              </a:lnSpc>
+              <a:buNone/>
+            </a:pPr>
+            <a:endParaRPr kumimoji="0" lang="en-US" altLang="en-US" sz="1200" b="0" i="0" u="none" strike="noStrike" cap="none" normalizeH="0" baseline="0">
+              <a:ln>
+                <a:noFill/>
+              </a:ln>
+              <a:solidFill>
+                <a:schemeClr val="tx1"/>
+              </a:solidFill>
+              <a:effectLst/>
+              <a:latin typeface="Arial" panose="020B0604020202020204" pitchFamily="34" charset="0"/>
+            </a:endParaRPr>
+          </a:p>
+        </p:txBody>
+      </p:sp>
+      <p:pic>
+        <p:nvPicPr>
+          <p:cNvPr id="4" name="Picture 3">
+            <a:extLst>
+              <a:ext uri="{FF2B5EF4-FFF2-40B4-BE49-F238E27FC236}">
+                <a16:creationId xmlns:a16="http://schemas.microsoft.com/office/drawing/2014/main" id="{00705BE4-5874-5452-78EE-1FEC8C25E610}"/>
+              </a:ext>
+            </a:extLst>
+          </p:cNvPr>
+          <p:cNvPicPr>
+            <a:picLocks noChangeAspect="1"/>
+          </p:cNvPicPr>
+          <p:nvPr/>
+        </p:nvPicPr>
+        <p:blipFill>
+          <a:blip r:embed="rId2"/>
+          <a:stretch>
+            <a:fillRect/>
+          </a:stretch>
+        </p:blipFill>
+        <p:spPr>
+          <a:xfrm>
+            <a:off x="3273715" y="1681018"/>
+            <a:ext cx="8918285" cy="5176982"/>
+          </a:xfrm>
+          <a:prstGeom prst="rect">
+            <a:avLst/>
+          </a:prstGeom>
+        </p:spPr>
+      </p:pic>
     </p:spTree>
     <p:extLst>
       <p:ext uri="{BB962C8B-B14F-4D97-AF65-F5344CB8AC3E}">
@@ -3470,6 +3571,36 @@
           </a:p>
         </p:txBody>
       </p:sp>
+      <p:pic>
+        <p:nvPicPr>
+          <p:cNvPr id="4" name="Picture 3">
+            <a:extLst>
+              <a:ext uri="{FF2B5EF4-FFF2-40B4-BE49-F238E27FC236}">
+                <a16:creationId xmlns:a16="http://schemas.microsoft.com/office/drawing/2014/main" id="{5319C117-33B2-7089-C22E-4908B4EABB53}"/>
+              </a:ext>
+            </a:extLst>
+          </p:cNvPr>
+          <p:cNvPicPr>
+            <a:picLocks noChangeAspect="1"/>
+          </p:cNvPicPr>
+          <p:nvPr/>
+        </p:nvPicPr>
+        <p:blipFill>
+          <a:blip r:embed="rId2"/>
+          <a:stretch>
+            <a:fillRect/>
+          </a:stretch>
+        </p:blipFill>
+        <p:spPr>
+          <a:xfrm>
+            <a:off x="6706973" y="0"/>
+            <a:ext cx="5485027" cy="6858000"/>
+          </a:xfrm>
+          <a:prstGeom prst="rect">
+            <a:avLst/>
+          </a:prstGeom>
+        </p:spPr>
+      </p:pic>
     </p:spTree>
     <p:extLst>
       <p:ext uri="{BB962C8B-B14F-4D97-AF65-F5344CB8AC3E}">
@@ -3484,6 +3615,865 @@
 </file>
 
 <file path=ppt/slides/slide3.xml><?xml version="1.0" encoding="utf-8"?>
+<p:sld xmlns:a="http://schemas.openxmlformats.org/drawingml/2006/main" xmlns:r="http://schemas.openxmlformats.org/officeDocument/2006/relationships" xmlns:p="http://schemas.openxmlformats.org/presentationml/2006/main">
+  <p:cSld>
+    <p:spTree>
+      <p:nvGrpSpPr>
+        <p:cNvPr id="1" name="">
+          <a:extLst>
+            <a:ext uri="{FF2B5EF4-FFF2-40B4-BE49-F238E27FC236}">
+              <a16:creationId xmlns:a16="http://schemas.microsoft.com/office/drawing/2014/main" id="{F2904E39-AD00-79CF-5864-8816829112C2}"/>
+            </a:ext>
+          </a:extLst>
+        </p:cNvPr>
+        <p:cNvGrpSpPr/>
+        <p:nvPr/>
+      </p:nvGrpSpPr>
+      <p:grpSpPr>
+        <a:xfrm>
+          <a:off x="0" y="0"/>
+          <a:ext cx="0" cy="0"/>
+          <a:chOff x="0" y="0"/>
+          <a:chExt cx="0" cy="0"/>
+        </a:xfrm>
+      </p:grpSpPr>
+      <p:sp>
+        <p:nvSpPr>
+          <p:cNvPr id="3" name="TextBox 2">
+            <a:extLst>
+              <a:ext uri="{FF2B5EF4-FFF2-40B4-BE49-F238E27FC236}">
+                <a16:creationId xmlns:a16="http://schemas.microsoft.com/office/drawing/2014/main" id="{1BA77681-2431-070F-2327-32D8613E1F9D}"/>
+              </a:ext>
+            </a:extLst>
+          </p:cNvPr>
+          <p:cNvSpPr txBox="1"/>
+          <p:nvPr/>
+        </p:nvSpPr>
+        <p:spPr>
+          <a:xfrm>
+            <a:off x="217714" y="255046"/>
+            <a:ext cx="11756571" cy="355354"/>
+          </a:xfrm>
+          <a:prstGeom prst="rect">
+            <a:avLst/>
+          </a:prstGeom>
+          <a:noFill/>
+        </p:spPr>
+        <p:txBody>
+          <a:bodyPr wrap="square">
+            <a:spAutoFit/>
+          </a:bodyPr>
+          <a:lstStyle/>
+          <a:p>
+            <a:pPr>
+              <a:lnSpc>
+                <a:spcPct val="150000"/>
+              </a:lnSpc>
+              <a:buNone/>
+            </a:pPr>
+            <a:r>
+              <a:rPr kumimoji="0" lang="en-US" altLang="en-US" sz="1300" b="0" i="0" u="none" strike="noStrike" cap="none" normalizeH="0" baseline="0">
+                <a:ln>
+                  <a:noFill/>
+                </a:ln>
+                <a:solidFill>
+                  <a:schemeClr val="tx1"/>
+                </a:solidFill>
+                <a:effectLst/>
+                <a:latin typeface="Arial" panose="020B0604020202020204" pitchFamily="34" charset="0"/>
+              </a:rPr>
+              <a:t>.</a:t>
+            </a:r>
+          </a:p>
+        </p:txBody>
+      </p:sp>
+      <p:pic>
+        <p:nvPicPr>
+          <p:cNvPr id="4" name="Picture 3">
+            <a:extLst>
+              <a:ext uri="{FF2B5EF4-FFF2-40B4-BE49-F238E27FC236}">
+                <a16:creationId xmlns:a16="http://schemas.microsoft.com/office/drawing/2014/main" id="{D905DDE2-3750-C07A-9C5B-B0FFC834738E}"/>
+              </a:ext>
+            </a:extLst>
+          </p:cNvPr>
+          <p:cNvPicPr>
+            <a:picLocks noChangeAspect="1"/>
+          </p:cNvPicPr>
+          <p:nvPr/>
+        </p:nvPicPr>
+        <p:blipFill>
+          <a:blip r:embed="rId2"/>
+          <a:stretch>
+            <a:fillRect/>
+          </a:stretch>
+        </p:blipFill>
+        <p:spPr>
+          <a:xfrm>
+            <a:off x="3308402" y="0"/>
+            <a:ext cx="8883598" cy="6858000"/>
+          </a:xfrm>
+          <a:prstGeom prst="rect">
+            <a:avLst/>
+          </a:prstGeom>
+        </p:spPr>
+      </p:pic>
+    </p:spTree>
+    <p:extLst>
+      <p:ext uri="{BB962C8B-B14F-4D97-AF65-F5344CB8AC3E}">
+        <p14:creationId xmlns:p14="http://schemas.microsoft.com/office/powerpoint/2010/main" val="3783387528"/>
+      </p:ext>
+    </p:extLst>
+  </p:cSld>
+  <p:clrMapOvr>
+    <a:masterClrMapping/>
+  </p:clrMapOvr>
+</p:sld>
+</file>
+
+<file path=ppt/slides/slide4.xml><?xml version="1.0" encoding="utf-8"?>
+<p:sld xmlns:a="http://schemas.openxmlformats.org/drawingml/2006/main" xmlns:r="http://schemas.openxmlformats.org/officeDocument/2006/relationships" xmlns:p="http://schemas.openxmlformats.org/presentationml/2006/main">
+  <p:cSld>
+    <p:spTree>
+      <p:nvGrpSpPr>
+        <p:cNvPr id="1" name="">
+          <a:extLst>
+            <a:ext uri="{FF2B5EF4-FFF2-40B4-BE49-F238E27FC236}">
+              <a16:creationId xmlns:a16="http://schemas.microsoft.com/office/drawing/2014/main" id="{09B84705-CA61-89F3-55B2-999CF40259DB}"/>
+            </a:ext>
+          </a:extLst>
+        </p:cNvPr>
+        <p:cNvGrpSpPr/>
+        <p:nvPr/>
+      </p:nvGrpSpPr>
+      <p:grpSpPr>
+        <a:xfrm>
+          <a:off x="0" y="0"/>
+          <a:ext cx="0" cy="0"/>
+          <a:chOff x="0" y="0"/>
+          <a:chExt cx="0" cy="0"/>
+        </a:xfrm>
+      </p:grpSpPr>
+      <p:sp>
+        <p:nvSpPr>
+          <p:cNvPr id="3" name="TextBox 2">
+            <a:extLst>
+              <a:ext uri="{FF2B5EF4-FFF2-40B4-BE49-F238E27FC236}">
+                <a16:creationId xmlns:a16="http://schemas.microsoft.com/office/drawing/2014/main" id="{CD3B01E0-E8B4-FA1C-7844-D2ECB81ACB47}"/>
+              </a:ext>
+            </a:extLst>
+          </p:cNvPr>
+          <p:cNvSpPr txBox="1"/>
+          <p:nvPr/>
+        </p:nvSpPr>
+        <p:spPr>
+          <a:xfrm>
+            <a:off x="217714" y="255046"/>
+            <a:ext cx="11756571" cy="355354"/>
+          </a:xfrm>
+          <a:prstGeom prst="rect">
+            <a:avLst/>
+          </a:prstGeom>
+          <a:noFill/>
+        </p:spPr>
+        <p:txBody>
+          <a:bodyPr wrap="square">
+            <a:spAutoFit/>
+          </a:bodyPr>
+          <a:lstStyle/>
+          <a:p>
+            <a:pPr>
+              <a:lnSpc>
+                <a:spcPct val="150000"/>
+              </a:lnSpc>
+              <a:buNone/>
+            </a:pPr>
+            <a:r>
+              <a:rPr kumimoji="0" lang="en-US" altLang="en-US" sz="1300" b="0" i="0" u="none" strike="noStrike" cap="none" normalizeH="0" baseline="0">
+                <a:ln>
+                  <a:noFill/>
+                </a:ln>
+                <a:solidFill>
+                  <a:schemeClr val="tx1"/>
+                </a:solidFill>
+                <a:effectLst/>
+                <a:latin typeface="Arial" panose="020B0604020202020204" pitchFamily="34" charset="0"/>
+              </a:rPr>
+              <a:t>.</a:t>
+            </a:r>
+          </a:p>
+        </p:txBody>
+      </p:sp>
+      <p:pic>
+        <p:nvPicPr>
+          <p:cNvPr id="4" name="Picture 3">
+            <a:extLst>
+              <a:ext uri="{FF2B5EF4-FFF2-40B4-BE49-F238E27FC236}">
+                <a16:creationId xmlns:a16="http://schemas.microsoft.com/office/drawing/2014/main" id="{1E248662-20AD-6854-8448-940530555D32}"/>
+              </a:ext>
+            </a:extLst>
+          </p:cNvPr>
+          <p:cNvPicPr>
+            <a:picLocks noChangeAspect="1"/>
+          </p:cNvPicPr>
+          <p:nvPr/>
+        </p:nvPicPr>
+        <p:blipFill>
+          <a:blip r:embed="rId2"/>
+          <a:stretch>
+            <a:fillRect/>
+          </a:stretch>
+        </p:blipFill>
+        <p:spPr>
+          <a:xfrm>
+            <a:off x="8401146" y="0"/>
+            <a:ext cx="3790854" cy="6858000"/>
+          </a:xfrm>
+          <a:prstGeom prst="rect">
+            <a:avLst/>
+          </a:prstGeom>
+        </p:spPr>
+      </p:pic>
+    </p:spTree>
+    <p:extLst>
+      <p:ext uri="{BB962C8B-B14F-4D97-AF65-F5344CB8AC3E}">
+        <p14:creationId xmlns:p14="http://schemas.microsoft.com/office/powerpoint/2010/main" val="2450199529"/>
+      </p:ext>
+    </p:extLst>
+  </p:cSld>
+  <p:clrMapOvr>
+    <a:masterClrMapping/>
+  </p:clrMapOvr>
+</p:sld>
+</file>
+
+<file path=ppt/slides/slide5.xml><?xml version="1.0" encoding="utf-8"?>
+<p:sld xmlns:a="http://schemas.openxmlformats.org/drawingml/2006/main" xmlns:r="http://schemas.openxmlformats.org/officeDocument/2006/relationships" xmlns:p="http://schemas.openxmlformats.org/presentationml/2006/main">
+  <p:cSld>
+    <p:spTree>
+      <p:nvGrpSpPr>
+        <p:cNvPr id="1" name="">
+          <a:extLst>
+            <a:ext uri="{FF2B5EF4-FFF2-40B4-BE49-F238E27FC236}">
+              <a16:creationId xmlns:a16="http://schemas.microsoft.com/office/drawing/2014/main" id="{1095612A-633C-DD02-CC55-D206088694BA}"/>
+            </a:ext>
+          </a:extLst>
+        </p:cNvPr>
+        <p:cNvGrpSpPr/>
+        <p:nvPr/>
+      </p:nvGrpSpPr>
+      <p:grpSpPr>
+        <a:xfrm>
+          <a:off x="0" y="0"/>
+          <a:ext cx="0" cy="0"/>
+          <a:chOff x="0" y="0"/>
+          <a:chExt cx="0" cy="0"/>
+        </a:xfrm>
+      </p:grpSpPr>
+      <p:sp>
+        <p:nvSpPr>
+          <p:cNvPr id="3" name="TextBox 2">
+            <a:extLst>
+              <a:ext uri="{FF2B5EF4-FFF2-40B4-BE49-F238E27FC236}">
+                <a16:creationId xmlns:a16="http://schemas.microsoft.com/office/drawing/2014/main" id="{1CF53A88-1275-14DC-16B0-703789EAECB0}"/>
+              </a:ext>
+            </a:extLst>
+          </p:cNvPr>
+          <p:cNvSpPr txBox="1"/>
+          <p:nvPr/>
+        </p:nvSpPr>
+        <p:spPr>
+          <a:xfrm>
+            <a:off x="0" y="43746"/>
+            <a:ext cx="6275294" cy="6770508"/>
+          </a:xfrm>
+          <a:prstGeom prst="rect">
+            <a:avLst/>
+          </a:prstGeom>
+          <a:noFill/>
+        </p:spPr>
+        <p:txBody>
+          <a:bodyPr wrap="square">
+            <a:spAutoFit/>
+          </a:bodyPr>
+          <a:lstStyle/>
+          <a:p>
+            <a:pPr>
+              <a:lnSpc>
+                <a:spcPct val="150000"/>
+              </a:lnSpc>
+              <a:buNone/>
+            </a:pPr>
+            <a:r>
+              <a:rPr lang="en-US" altLang="en-US" sz="1100">
+                <a:latin typeface="Arial" panose="020B0604020202020204" pitchFamily="34" charset="0"/>
+              </a:rPr>
+              <a:t>Bu kod parçası, </a:t>
+            </a:r>
+            <a:r>
+              <a:rPr lang="en-US" altLang="en-US" sz="1100" b="1">
+                <a:latin typeface="Arial" panose="020B0604020202020204" pitchFamily="34" charset="0"/>
+              </a:rPr>
+              <a:t>ProductDataTable</a:t>
+            </a:r>
+            <a:r>
+              <a:rPr lang="en-US" altLang="en-US" sz="1100">
+                <a:latin typeface="Arial" panose="020B0604020202020204" pitchFamily="34" charset="0"/>
+              </a:rPr>
+              <a:t> sinifindəki </a:t>
+            </a:r>
+            <a:r>
+              <a:rPr lang="en-US" altLang="en-US" sz="1100" b="1">
+                <a:latin typeface="Arial" panose="020B0604020202020204" pitchFamily="34" charset="0"/>
+              </a:rPr>
+              <a:t>query</a:t>
+            </a:r>
+            <a:r>
+              <a:rPr lang="en-US" altLang="en-US" sz="1100">
+                <a:latin typeface="Arial" panose="020B0604020202020204" pitchFamily="34" charset="0"/>
+              </a:rPr>
+              <a:t> metodunda istifadə olunur və verilənlər bazasından </a:t>
+            </a:r>
+            <a:r>
+              <a:rPr lang="en-US" altLang="en-US" sz="1100" b="1" i="1">
+                <a:latin typeface="Arial" panose="020B0604020202020204" pitchFamily="34" charset="0"/>
+              </a:rPr>
+              <a:t>məhsulları filtrləyən </a:t>
+            </a:r>
+            <a:r>
+              <a:rPr lang="en-US" altLang="en-US" sz="1100">
+                <a:latin typeface="Arial" panose="020B0604020202020204" pitchFamily="34" charset="0"/>
+              </a:rPr>
+              <a:t>bir hissədir. Buradakı hissənin məqsədi, yalnız istifadəçinin əlaqəli olduğu </a:t>
+            </a:r>
+            <a:r>
+              <a:rPr lang="en-US" altLang="en-US" sz="1100" b="1">
+                <a:solidFill>
+                  <a:srgbClr val="FF0000"/>
+                </a:solidFill>
+                <a:latin typeface="Arial" panose="020B0604020202020204" pitchFamily="34" charset="0"/>
+              </a:rPr>
+              <a:t>vendor</a:t>
+            </a:r>
+            <a:r>
+              <a:rPr lang="en-US" altLang="en-US" sz="1100">
+                <a:latin typeface="Arial" panose="020B0604020202020204" pitchFamily="34" charset="0"/>
+              </a:rPr>
+              <a:t> (satıcı) ilə əlaqəli olan məhsulları gətirməkdir. Gəlin bu hissəni daha dərindən analiz edək:</a:t>
+            </a:r>
+            <a:endParaRPr lang="az-Latn-AZ" altLang="en-US" sz="1100">
+              <a:latin typeface="Arial" panose="020B0604020202020204" pitchFamily="34" charset="0"/>
+            </a:endParaRPr>
+          </a:p>
+          <a:p>
+            <a:pPr>
+              <a:lnSpc>
+                <a:spcPct val="150000"/>
+              </a:lnSpc>
+              <a:buNone/>
+            </a:pPr>
+            <a:endParaRPr kumimoji="0" lang="az-Latn-AZ" altLang="en-US" sz="1100" b="0" i="0" u="none" strike="noStrike" cap="none" normalizeH="0" baseline="0">
+              <a:ln>
+                <a:noFill/>
+              </a:ln>
+              <a:solidFill>
+                <a:schemeClr val="tx1"/>
+              </a:solidFill>
+              <a:effectLst/>
+              <a:latin typeface="Arial" panose="020B0604020202020204" pitchFamily="34" charset="0"/>
+            </a:endParaRPr>
+          </a:p>
+          <a:p>
+            <a:pPr>
+              <a:lnSpc>
+                <a:spcPct val="150000"/>
+              </a:lnSpc>
+              <a:buNone/>
+            </a:pPr>
+            <a:endParaRPr lang="az-Latn-AZ" altLang="en-US" sz="1100">
+              <a:latin typeface="Arial" panose="020B0604020202020204" pitchFamily="34" charset="0"/>
+            </a:endParaRPr>
+          </a:p>
+          <a:p>
+            <a:r>
+              <a:rPr lang="en-US" sz="1100"/>
+              <a:t>1) </a:t>
+            </a:r>
+            <a:r>
+              <a:rPr lang="en-US" sz="1100" b="1"/>
+              <a:t>$model: </a:t>
+            </a:r>
+            <a:r>
+              <a:rPr lang="en-US" sz="1100"/>
+              <a:t>Bu, Product modelini təmsil edir və bu model, verilənlər bazasındakı products cədvəlini idarə edir.</a:t>
+            </a:r>
+          </a:p>
+          <a:p>
+            <a:br>
+              <a:rPr lang="en-US" sz="1100"/>
+            </a:br>
+            <a:endParaRPr lang="en-US" sz="1100"/>
+          </a:p>
+          <a:p>
+            <a:r>
+              <a:rPr lang="en-US" sz="1100"/>
+              <a:t>2) </a:t>
+            </a:r>
+            <a:r>
+              <a:rPr lang="en-US" sz="1100" b="1"/>
+              <a:t>where('vendor_id', ...)</a:t>
+            </a:r>
+            <a:r>
+              <a:rPr lang="en-US" sz="1100"/>
+              <a:t>: Bu, SQL sorğusuna bir şərt əlavə edir. Burada vendor_id sütununu istifadə edərək yalnız müəyyən bir vendor-a (satıcıya) aid olan məhsulları seçirik.</a:t>
+            </a:r>
+          </a:p>
+          <a:p>
+            <a:pPr marL="171450" indent="-171450">
+              <a:lnSpc>
+                <a:spcPct val="150000"/>
+              </a:lnSpc>
+              <a:buFont typeface="Wingdings" panose="05000000000000000000" pitchFamily="2" charset="2"/>
+              <a:buChar char="q"/>
+            </a:pPr>
+            <a:r>
+              <a:rPr lang="en-US" sz="1100" b="1"/>
+              <a:t>vendor_id</a:t>
+            </a:r>
+            <a:r>
+              <a:rPr lang="en-US" sz="1100"/>
+              <a:t>, </a:t>
+            </a:r>
+            <a:r>
+              <a:rPr lang="en-US" sz="1100" b="1"/>
+              <a:t>products</a:t>
+            </a:r>
+            <a:r>
+              <a:rPr lang="en-US" sz="1100"/>
+              <a:t> cədvəlində hər bir məhsulun hansı satıcıya aid olduğunu göstərən bir sütundur.</a:t>
+            </a:r>
+          </a:p>
+          <a:p>
+            <a:br>
+              <a:rPr lang="en-US" sz="1100"/>
+            </a:br>
+            <a:endParaRPr lang="en-US" sz="1100"/>
+          </a:p>
+          <a:p>
+            <a:r>
+              <a:rPr lang="en-US" sz="1100"/>
+              <a:t>3) </a:t>
+            </a:r>
+            <a:r>
+              <a:rPr lang="en-US" sz="1100" b="1" i="1"/>
+              <a:t>Auth</a:t>
+            </a:r>
+            <a:r>
+              <a:rPr lang="en-US" sz="1100" b="1"/>
+              <a:t>::user()-&gt;vendor-&gt;id</a:t>
+            </a:r>
+            <a:r>
+              <a:rPr lang="en-US" sz="1100"/>
+              <a:t>:</a:t>
+            </a:r>
+          </a:p>
+          <a:p>
+            <a:pPr marL="171450" indent="-171450">
+              <a:lnSpc>
+                <a:spcPct val="150000"/>
+              </a:lnSpc>
+              <a:buFont typeface="Wingdings" panose="05000000000000000000" pitchFamily="2" charset="2"/>
+              <a:buChar char="q"/>
+            </a:pPr>
+            <a:r>
+              <a:rPr lang="en-US" sz="1100"/>
+              <a:t>Bu, giriş etmiş istifadəçinin (authentikasiya edilmiş istifadəçi) əlaqəli olduğu </a:t>
+            </a:r>
+            <a:r>
+              <a:rPr lang="en-US" sz="1100" b="1"/>
+              <a:t>vendor</a:t>
+            </a:r>
+            <a:r>
+              <a:rPr lang="en-US" sz="1100"/>
+              <a:t>-ın </a:t>
+            </a:r>
+            <a:r>
+              <a:rPr lang="en-US" sz="1100" b="1"/>
+              <a:t>id</a:t>
+            </a:r>
+            <a:r>
+              <a:rPr lang="en-US" sz="1100"/>
+              <a:t>-sini əldə edir.</a:t>
+            </a:r>
+          </a:p>
+          <a:p>
+            <a:pPr marL="171450" indent="-171450">
+              <a:lnSpc>
+                <a:spcPct val="150000"/>
+              </a:lnSpc>
+              <a:buFont typeface="Wingdings" panose="05000000000000000000" pitchFamily="2" charset="2"/>
+              <a:buChar char="q"/>
+            </a:pPr>
+            <a:r>
+              <a:rPr lang="en-US" sz="1100" b="1" i="1"/>
+              <a:t>Auth</a:t>
+            </a:r>
+            <a:r>
+              <a:rPr lang="en-US" sz="1100" b="1"/>
+              <a:t>::user() </a:t>
+            </a:r>
+            <a:r>
+              <a:rPr lang="en-US" sz="1100"/>
+              <a:t>funksiyası, sistemə daxil olmuş istifadəçini təmsil edir.</a:t>
+            </a:r>
+          </a:p>
+          <a:p>
+            <a:pPr marL="171450" indent="-171450">
+              <a:lnSpc>
+                <a:spcPct val="150000"/>
+              </a:lnSpc>
+              <a:buFont typeface="Wingdings" panose="05000000000000000000" pitchFamily="2" charset="2"/>
+              <a:buChar char="q"/>
+            </a:pPr>
+            <a:r>
+              <a:rPr lang="en-US" sz="1100" b="1"/>
+              <a:t>.vendor </a:t>
+            </a:r>
+            <a:r>
+              <a:rPr lang="en-US" sz="1100"/>
+              <a:t>burada istifadəçinin əlaqəli olduğu satıcıyı göstərir. (Əgər istifadəçi bir vendor-a bağlıdırsa, bu əlaqə ehtimal ki, </a:t>
+            </a:r>
+            <a:r>
+              <a:rPr lang="en-US" sz="1100" b="1"/>
+              <a:t>User</a:t>
+            </a:r>
+            <a:r>
+              <a:rPr lang="en-US" sz="1100"/>
+              <a:t> modelində </a:t>
+            </a:r>
+            <a:r>
+              <a:rPr lang="en-US" sz="1100" b="1"/>
+              <a:t>vendor</a:t>
+            </a:r>
+            <a:r>
+              <a:rPr lang="en-US" sz="1100"/>
+              <a:t> ilə əlaqəlidir).</a:t>
+            </a:r>
+          </a:p>
+          <a:p>
+            <a:pPr marL="171450" indent="-171450">
+              <a:lnSpc>
+                <a:spcPct val="150000"/>
+              </a:lnSpc>
+              <a:buFont typeface="Wingdings" panose="05000000000000000000" pitchFamily="2" charset="2"/>
+              <a:buChar char="q"/>
+            </a:pPr>
+            <a:r>
+              <a:rPr lang="en-US" sz="1100" b="1"/>
+              <a:t>.id </a:t>
+            </a:r>
+            <a:r>
+              <a:rPr lang="en-US" sz="1100"/>
+              <a:t>isə həmin </a:t>
+            </a:r>
+            <a:r>
+              <a:rPr lang="en-US" sz="1100" b="1"/>
+              <a:t>vendor</a:t>
+            </a:r>
+            <a:r>
+              <a:rPr lang="en-US" sz="1100"/>
+              <a:t>-un </a:t>
+            </a:r>
+            <a:r>
+              <a:rPr lang="en-US" sz="1100" b="1"/>
+              <a:t>ID</a:t>
+            </a:r>
+            <a:r>
+              <a:rPr lang="en-US" sz="1100"/>
+              <a:t>-sini götürür.</a:t>
+            </a:r>
+          </a:p>
+          <a:p>
+            <a:br>
+              <a:rPr lang="en-US" sz="1100"/>
+            </a:br>
+            <a:endParaRPr lang="en-US" sz="1100"/>
+          </a:p>
+          <a:p>
+            <a:r>
+              <a:rPr lang="en-US" sz="1100"/>
+              <a:t>4) </a:t>
+            </a:r>
+            <a:r>
+              <a:rPr lang="en-US" sz="1100" b="1"/>
+              <a:t>newQuery()</a:t>
+            </a:r>
+            <a:r>
+              <a:rPr lang="en-US" sz="1100"/>
+              <a:t>: Bu metod, yeni bir </a:t>
+            </a:r>
+            <a:r>
+              <a:rPr lang="en-US" sz="1100" b="1"/>
+              <a:t>QueryBuilder</a:t>
+            </a:r>
+            <a:r>
+              <a:rPr lang="en-US" sz="1100"/>
+              <a:t> obyekti qaytarır. </a:t>
+            </a:r>
+            <a:r>
+              <a:rPr lang="en-US" sz="1100" b="1"/>
+              <a:t>where</a:t>
+            </a:r>
+            <a:r>
+              <a:rPr lang="en-US" sz="1100"/>
+              <a:t> şərtini əlavə etdikdən sonra yeni bir sorğu qurulur.</a:t>
+            </a:r>
+          </a:p>
+          <a:p>
+            <a:pPr>
+              <a:lnSpc>
+                <a:spcPct val="150000"/>
+              </a:lnSpc>
+              <a:buNone/>
+            </a:pPr>
+            <a:endParaRPr kumimoji="0" lang="az-Latn-AZ" altLang="en-US" sz="1100" b="0" i="0" u="none" strike="noStrike" cap="none" normalizeH="0" baseline="0">
+              <a:ln>
+                <a:noFill/>
+              </a:ln>
+              <a:solidFill>
+                <a:schemeClr val="tx1"/>
+              </a:solidFill>
+              <a:effectLst/>
+              <a:latin typeface="Arial" panose="020B0604020202020204" pitchFamily="34" charset="0"/>
+            </a:endParaRPr>
+          </a:p>
+          <a:p>
+            <a:r>
+              <a:rPr lang="en-US" sz="1100"/>
+              <a:t>Bu kod hissəsi, yalnız </a:t>
+            </a:r>
+            <a:r>
+              <a:rPr lang="en-US" sz="1100" b="1"/>
+              <a:t>giriş etmiş istifadəçinin əlaqəli olduğu vendor-a aid olan məhsulları</a:t>
+            </a:r>
+            <a:r>
+              <a:rPr lang="en-US" sz="1100"/>
+              <a:t> almağa xidmət edir. Yəni, hər istifadəçi yalnız öz vendor-u ilə əlaqəli məhsulları görəcək. Əgər bir satıcı (vendor) yalnız öz məhsullarını idarə etmək istəyirsə, bu şərt onun üçün doğru olan məhsulları göstərəcək.</a:t>
+            </a:r>
+            <a:endParaRPr lang="az-Latn-AZ" sz="1100"/>
+          </a:p>
+          <a:p>
+            <a:endParaRPr lang="en-US" sz="1100"/>
+          </a:p>
+          <a:p>
+            <a:r>
+              <a:rPr lang="en-US" sz="1100"/>
+              <a:t>Məsələn, əgər istifadəçi </a:t>
+            </a:r>
+            <a:r>
+              <a:rPr lang="en-US" sz="1100" b="1"/>
+              <a:t>vendor_id</a:t>
+            </a:r>
+            <a:r>
+              <a:rPr lang="en-US" sz="1100"/>
+              <a:t>-si </a:t>
+            </a:r>
+            <a:r>
+              <a:rPr lang="en-US" sz="1100" b="1"/>
+              <a:t>5</a:t>
+            </a:r>
+            <a:r>
+              <a:rPr lang="en-US" sz="1100"/>
+              <a:t> olan bir vendor-a aid idisə, yalnız </a:t>
+            </a:r>
+            <a:r>
+              <a:rPr lang="en-US" sz="1100" b="1" i="1">
+                <a:solidFill>
+                  <a:srgbClr val="FF0000"/>
+                </a:solidFill>
+              </a:rPr>
+              <a:t>vendor_id = 5</a:t>
+            </a:r>
+            <a:r>
+              <a:rPr lang="en-US" sz="1100"/>
+              <a:t> olan məhsullar verilənlər bazasından çəkiləcək.</a:t>
+            </a:r>
+          </a:p>
+        </p:txBody>
+      </p:sp>
+      <p:pic>
+        <p:nvPicPr>
+          <p:cNvPr id="4" name="Picture 3">
+            <a:extLst>
+              <a:ext uri="{FF2B5EF4-FFF2-40B4-BE49-F238E27FC236}">
+                <a16:creationId xmlns:a16="http://schemas.microsoft.com/office/drawing/2014/main" id="{6E7A6E82-1C74-87F1-5C45-558B9E28682A}"/>
+              </a:ext>
+            </a:extLst>
+          </p:cNvPr>
+          <p:cNvPicPr>
+            <a:picLocks noChangeAspect="1"/>
+          </p:cNvPicPr>
+          <p:nvPr/>
+        </p:nvPicPr>
+        <p:blipFill>
+          <a:blip r:embed="rId2"/>
+          <a:stretch>
+            <a:fillRect/>
+          </a:stretch>
+        </p:blipFill>
+        <p:spPr>
+          <a:xfrm>
+            <a:off x="6275294" y="0"/>
+            <a:ext cx="5916706" cy="6858000"/>
+          </a:xfrm>
+          <a:prstGeom prst="rect">
+            <a:avLst/>
+          </a:prstGeom>
+        </p:spPr>
+      </p:pic>
+    </p:spTree>
+    <p:extLst>
+      <p:ext uri="{BB962C8B-B14F-4D97-AF65-F5344CB8AC3E}">
+        <p14:creationId xmlns:p14="http://schemas.microsoft.com/office/powerpoint/2010/main" val="1104096269"/>
+      </p:ext>
+    </p:extLst>
+  </p:cSld>
+  <p:clrMapOvr>
+    <a:masterClrMapping/>
+  </p:clrMapOvr>
+</p:sld>
+</file>
+
+<file path=ppt/slides/slide6.xml><?xml version="1.0" encoding="utf-8"?>
+<p:sld xmlns:a="http://schemas.openxmlformats.org/drawingml/2006/main" xmlns:r="http://schemas.openxmlformats.org/officeDocument/2006/relationships" xmlns:p="http://schemas.openxmlformats.org/presentationml/2006/main">
+  <p:cSld>
+    <p:spTree>
+      <p:nvGrpSpPr>
+        <p:cNvPr id="1" name="">
+          <a:extLst>
+            <a:ext uri="{FF2B5EF4-FFF2-40B4-BE49-F238E27FC236}">
+              <a16:creationId xmlns:a16="http://schemas.microsoft.com/office/drawing/2014/main" id="{C9ECE65D-07E4-F8C4-E79A-9625BFA12F82}"/>
+            </a:ext>
+          </a:extLst>
+        </p:cNvPr>
+        <p:cNvGrpSpPr/>
+        <p:nvPr/>
+      </p:nvGrpSpPr>
+      <p:grpSpPr>
+        <a:xfrm>
+          <a:off x="0" y="0"/>
+          <a:ext cx="0" cy="0"/>
+          <a:chOff x="0" y="0"/>
+          <a:chExt cx="0" cy="0"/>
+        </a:xfrm>
+      </p:grpSpPr>
+      <p:sp>
+        <p:nvSpPr>
+          <p:cNvPr id="3" name="TextBox 2">
+            <a:extLst>
+              <a:ext uri="{FF2B5EF4-FFF2-40B4-BE49-F238E27FC236}">
+                <a16:creationId xmlns:a16="http://schemas.microsoft.com/office/drawing/2014/main" id="{E29DC613-5CE5-E827-5DC4-5890119AAC95}"/>
+              </a:ext>
+            </a:extLst>
+          </p:cNvPr>
+          <p:cNvSpPr txBox="1"/>
+          <p:nvPr/>
+        </p:nvSpPr>
+        <p:spPr>
+          <a:xfrm>
+            <a:off x="217714" y="255046"/>
+            <a:ext cx="11756571" cy="355354"/>
+          </a:xfrm>
+          <a:prstGeom prst="rect">
+            <a:avLst/>
+          </a:prstGeom>
+          <a:noFill/>
+        </p:spPr>
+        <p:txBody>
+          <a:bodyPr wrap="square">
+            <a:spAutoFit/>
+          </a:bodyPr>
+          <a:lstStyle/>
+          <a:p>
+            <a:pPr>
+              <a:lnSpc>
+                <a:spcPct val="150000"/>
+              </a:lnSpc>
+              <a:buNone/>
+            </a:pPr>
+            <a:r>
+              <a:rPr kumimoji="0" lang="en-US" altLang="en-US" sz="1300" b="0" i="0" u="none" strike="noStrike" cap="none" normalizeH="0" baseline="0">
+                <a:ln>
+                  <a:noFill/>
+                </a:ln>
+                <a:solidFill>
+                  <a:schemeClr val="tx1"/>
+                </a:solidFill>
+                <a:effectLst/>
+                <a:latin typeface="Arial" panose="020B0604020202020204" pitchFamily="34" charset="0"/>
+              </a:rPr>
+              <a:t>.</a:t>
+            </a:r>
+          </a:p>
+        </p:txBody>
+      </p:sp>
+      <p:pic>
+        <p:nvPicPr>
+          <p:cNvPr id="4" name="Picture 3">
+            <a:extLst>
+              <a:ext uri="{FF2B5EF4-FFF2-40B4-BE49-F238E27FC236}">
+                <a16:creationId xmlns:a16="http://schemas.microsoft.com/office/drawing/2014/main" id="{BD7CDCD5-B42B-C527-359F-B0BF50F54682}"/>
+              </a:ext>
+            </a:extLst>
+          </p:cNvPr>
+          <p:cNvPicPr>
+            <a:picLocks noChangeAspect="1"/>
+          </p:cNvPicPr>
+          <p:nvPr/>
+        </p:nvPicPr>
+        <p:blipFill>
+          <a:blip r:embed="rId2"/>
+          <a:stretch>
+            <a:fillRect/>
+          </a:stretch>
+        </p:blipFill>
+        <p:spPr>
+          <a:xfrm>
+            <a:off x="0" y="2976128"/>
+            <a:ext cx="12192000" cy="3881872"/>
+          </a:xfrm>
+          <a:prstGeom prst="rect">
+            <a:avLst/>
+          </a:prstGeom>
+          <a:ln w="38100" cap="sq">
+            <a:solidFill>
+              <a:srgbClr val="000000"/>
+            </a:solidFill>
+            <a:prstDash val="solid"/>
+            <a:miter lim="800000"/>
+          </a:ln>
+          <a:effectLst>
+            <a:outerShdw blurRad="50800" dist="38100" dir="2700000" algn="tl" rotWithShape="0">
+              <a:srgbClr val="000000">
+                <a:alpha val="43000"/>
+              </a:srgbClr>
+            </a:outerShdw>
+          </a:effectLst>
+        </p:spPr>
+      </p:pic>
+    </p:spTree>
+    <p:extLst>
+      <p:ext uri="{BB962C8B-B14F-4D97-AF65-F5344CB8AC3E}">
+        <p14:creationId xmlns:p14="http://schemas.microsoft.com/office/powerpoint/2010/main" val="1333269301"/>
+      </p:ext>
+    </p:extLst>
+  </p:cSld>
+  <p:clrMapOvr>
+    <a:masterClrMapping/>
+  </p:clrMapOvr>
+</p:sld>
+</file>
+
+<file path=ppt/slides/slide7.xml><?xml version="1.0" encoding="utf-8"?>
 <p:sld xmlns:a="http://schemas.openxmlformats.org/drawingml/2006/main" xmlns:r="http://schemas.openxmlformats.org/officeDocument/2006/relationships" xmlns:p="http://schemas.openxmlformats.org/presentationml/2006/main">
   <p:cSld>
     <p:spTree>

</xml_diff>